<commit_message>
chore(kit): mudanca de licenca para MIT + apresentacao v1.3.0
- LICENSE.md: comercial proprietaria -> open-source MIT (autoria de
  Kasuo preservada no copyright)
- README: rodape atualizado para "Open-source sob Licenca MIT"
- Apresentacao-Metodo-Norte.pptx: rodape (slide 11) para v1.3.0 + MIT;
  cartao de licenca (slide 8) reescrito; sem "todos os direitos reservados"
- tools/atualizar-apresentacao.py: script de atualizacao cirurgica do
  pptx, com as substituicoes v1.1->v1.3.0 + licenca
- CHANGELOG: registra a mudanca de licenca na v1.3.0

Verificado por observacao: textos conferidos no pptx apos gerar.

Co-Authored-By: Claude Opus 4.8 <noreply@anthropic.com>
</commit_message>
<xml_diff>
--- a/Apresentacao-Metodo-Norte.pptx
+++ b/Apresentacao-Metodo-Norte.pptx
@@ -1788,6 +1788,10 @@
             <a:prstDash val="solid"/>
           </a:ln>
         </p:spPr>
+        <p:txBody>
+          <a:bodyPr/>
+          <a:p/>
+        </p:txBody>
       </p:sp>
       <p:sp>
         <p:nvSpPr>
@@ -1812,6 +1816,10 @@
             <a:prstDash val="solid"/>
           </a:ln>
         </p:spPr>
+        <p:txBody>
+          <a:bodyPr/>
+          <a:p/>
+        </p:txBody>
       </p:sp>
       <p:sp>
         <p:nvSpPr>
@@ -1832,6 +1840,10 @@
           </a:solidFill>
           <a:ln/>
         </p:spPr>
+        <p:txBody>
+          <a:bodyPr/>
+          <a:p/>
+        </p:txBody>
       </p:sp>
       <p:pic>
         <p:nvPicPr>
@@ -2168,6 +2180,10 @@
             </a:outerShdw>
           </a:effectLst>
         </p:spPr>
+        <p:txBody>
+          <a:bodyPr/>
+          <a:p/>
+        </p:txBody>
       </p:sp>
       <p:sp>
         <p:nvSpPr>
@@ -2188,6 +2204,10 @@
           </a:solidFill>
           <a:ln/>
         </p:spPr>
+        <p:txBody>
+          <a:bodyPr/>
+          <a:p/>
+        </p:txBody>
       </p:sp>
       <p:pic>
         <p:nvPicPr>
@@ -2319,6 +2339,10 @@
             </a:outerShdw>
           </a:effectLst>
         </p:spPr>
+        <p:txBody>
+          <a:bodyPr/>
+          <a:p/>
+        </p:txBody>
       </p:sp>
       <p:sp>
         <p:nvSpPr>
@@ -2339,6 +2363,10 @@
           </a:solidFill>
           <a:ln/>
         </p:spPr>
+        <p:txBody>
+          <a:bodyPr/>
+          <a:p/>
+        </p:txBody>
       </p:sp>
       <p:pic>
         <p:nvPicPr>
@@ -2470,6 +2498,10 @@
             </a:outerShdw>
           </a:effectLst>
         </p:spPr>
+        <p:txBody>
+          <a:bodyPr/>
+          <a:p/>
+        </p:txBody>
       </p:sp>
       <p:sp>
         <p:nvSpPr>
@@ -2490,6 +2522,10 @@
           </a:solidFill>
           <a:ln/>
         </p:spPr>
+        <p:txBody>
+          <a:bodyPr/>
+          <a:p/>
+        </p:txBody>
       </p:sp>
       <p:pic>
         <p:nvPicPr>
@@ -2687,6 +2723,10 @@
             <a:prstDash val="solid"/>
           </a:ln>
         </p:spPr>
+        <p:txBody>
+          <a:bodyPr/>
+          <a:p/>
+        </p:txBody>
       </p:sp>
       <p:sp>
         <p:nvSpPr>
@@ -2707,6 +2747,10 @@
           </a:solidFill>
           <a:ln/>
         </p:spPr>
+        <p:txBody>
+          <a:bodyPr/>
+          <a:p/>
+        </p:txBody>
       </p:sp>
       <p:pic>
         <p:nvPicPr>
@@ -2831,6 +2875,10 @@
           </a:solidFill>
           <a:ln/>
         </p:spPr>
+        <p:txBody>
+          <a:bodyPr/>
+          <a:p/>
+        </p:txBody>
       </p:sp>
       <p:sp>
         <p:nvSpPr>
@@ -2943,7 +2991,7 @@
                 <a:ea typeface="Calibri" pitchFamily="34" charset="-122"/>
                 <a:cs typeface="Calibri" pitchFamily="34" charset="-120"/>
               </a:rPr>
-              <a:t>Método Norte v1.0 · © 2026 Kasuo · Todos os direitos reservados</a:t>
+              <a:t>Método Norte v1.3.0 · © 2026 Kasuo · Open-source (Licença MIT)</a:t>
             </a:r>
             <a:endParaRPr lang="en-US" sz="1000" dirty="0"/>
           </a:p>
@@ -3087,6 +3135,10 @@
             </a:outerShdw>
           </a:effectLst>
         </p:spPr>
+        <p:txBody>
+          <a:bodyPr/>
+          <a:p/>
+        </p:txBody>
       </p:sp>
       <p:sp>
         <p:nvSpPr>
@@ -3107,6 +3159,10 @@
           </a:solidFill>
           <a:ln/>
         </p:spPr>
+        <p:txBody>
+          <a:bodyPr/>
+          <a:p/>
+        </p:txBody>
       </p:sp>
       <p:pic>
         <p:nvPicPr>
@@ -3238,6 +3294,10 @@
             </a:outerShdw>
           </a:effectLst>
         </p:spPr>
+        <p:txBody>
+          <a:bodyPr/>
+          <a:p/>
+        </p:txBody>
       </p:sp>
       <p:sp>
         <p:nvSpPr>
@@ -3258,6 +3318,10 @@
           </a:solidFill>
           <a:ln/>
         </p:spPr>
+        <p:txBody>
+          <a:bodyPr/>
+          <a:p/>
+        </p:txBody>
       </p:sp>
       <p:pic>
         <p:nvPicPr>
@@ -3389,6 +3453,10 @@
             </a:outerShdw>
           </a:effectLst>
         </p:spPr>
+        <p:txBody>
+          <a:bodyPr/>
+          <a:p/>
+        </p:txBody>
       </p:sp>
       <p:sp>
         <p:nvSpPr>
@@ -3409,6 +3477,10 @@
           </a:solidFill>
           <a:ln/>
         </p:spPr>
+        <p:txBody>
+          <a:bodyPr/>
+          <a:p/>
+        </p:txBody>
       </p:sp>
       <p:pic>
         <p:nvPicPr>
@@ -3540,6 +3612,10 @@
             </a:outerShdw>
           </a:effectLst>
         </p:spPr>
+        <p:txBody>
+          <a:bodyPr/>
+          <a:p/>
+        </p:txBody>
       </p:sp>
       <p:sp>
         <p:nvSpPr>
@@ -3560,6 +3636,10 @@
           </a:solidFill>
           <a:ln/>
         </p:spPr>
+        <p:txBody>
+          <a:bodyPr/>
+          <a:p/>
+        </p:txBody>
       </p:sp>
       <p:pic>
         <p:nvPicPr>
@@ -3755,6 +3835,10 @@
           </a:solidFill>
           <a:ln/>
         </p:spPr>
+        <p:txBody>
+          <a:bodyPr/>
+          <a:p/>
+        </p:txBody>
       </p:sp>
       <p:sp>
         <p:nvSpPr>
@@ -3901,6 +3985,10 @@
           </a:solidFill>
           <a:ln/>
         </p:spPr>
+        <p:txBody>
+          <a:bodyPr/>
+          <a:p/>
+        </p:txBody>
       </p:sp>
       <p:sp>
         <p:nvSpPr>
@@ -4047,6 +4135,10 @@
           </a:solidFill>
           <a:ln/>
         </p:spPr>
+        <p:txBody>
+          <a:bodyPr/>
+          <a:p/>
+        </p:txBody>
       </p:sp>
       <p:sp>
         <p:nvSpPr>
@@ -4246,6 +4338,10 @@
           </a:solidFill>
           <a:ln/>
         </p:spPr>
+        <p:txBody>
+          <a:bodyPr/>
+          <a:p/>
+        </p:txBody>
       </p:sp>
       <p:sp>
         <p:nvSpPr>
@@ -4266,6 +4362,10 @@
           </a:solidFill>
           <a:ln/>
         </p:spPr>
+        <p:txBody>
+          <a:bodyPr/>
+          <a:p/>
+        </p:txBody>
       </p:sp>
       <p:sp>
         <p:nvSpPr>
@@ -4405,6 +4505,10 @@
           </a:solidFill>
           <a:ln/>
         </p:spPr>
+        <p:txBody>
+          <a:bodyPr/>
+          <a:p/>
+        </p:txBody>
       </p:sp>
       <p:sp>
         <p:nvSpPr>
@@ -4425,6 +4529,10 @@
           </a:solidFill>
           <a:ln/>
         </p:spPr>
+        <p:txBody>
+          <a:bodyPr/>
+          <a:p/>
+        </p:txBody>
       </p:sp>
       <p:sp>
         <p:nvSpPr>
@@ -4564,6 +4672,10 @@
           </a:solidFill>
           <a:ln/>
         </p:spPr>
+        <p:txBody>
+          <a:bodyPr/>
+          <a:p/>
+        </p:txBody>
       </p:sp>
       <p:sp>
         <p:nvSpPr>
@@ -4584,6 +4696,10 @@
           </a:solidFill>
           <a:ln/>
         </p:spPr>
+        <p:txBody>
+          <a:bodyPr/>
+          <a:p/>
+        </p:txBody>
       </p:sp>
       <p:sp>
         <p:nvSpPr>
@@ -4723,6 +4839,10 @@
           </a:solidFill>
           <a:ln/>
         </p:spPr>
+        <p:txBody>
+          <a:bodyPr/>
+          <a:p/>
+        </p:txBody>
       </p:sp>
       <p:sp>
         <p:nvSpPr>
@@ -4743,6 +4863,10 @@
           </a:solidFill>
           <a:ln/>
         </p:spPr>
+        <p:txBody>
+          <a:bodyPr/>
+          <a:p/>
+        </p:txBody>
       </p:sp>
       <p:sp>
         <p:nvSpPr>
@@ -4882,6 +5006,10 @@
           </a:solidFill>
           <a:ln/>
         </p:spPr>
+        <p:txBody>
+          <a:bodyPr/>
+          <a:p/>
+        </p:txBody>
       </p:sp>
       <p:sp>
         <p:nvSpPr>
@@ -4902,6 +5030,10 @@
           </a:solidFill>
           <a:ln/>
         </p:spPr>
+        <p:txBody>
+          <a:bodyPr/>
+          <a:p/>
+        </p:txBody>
       </p:sp>
       <p:sp>
         <p:nvSpPr>
@@ -5151,6 +5283,10 @@
           </a:solidFill>
           <a:ln/>
         </p:spPr>
+        <p:txBody>
+          <a:bodyPr/>
+          <a:p/>
+        </p:txBody>
       </p:sp>
       <p:sp>
         <p:nvSpPr>
@@ -5171,6 +5307,10 @@
           </a:solidFill>
           <a:ln/>
         </p:spPr>
+        <p:txBody>
+          <a:bodyPr/>
+          <a:p/>
+        </p:txBody>
       </p:sp>
       <p:pic>
         <p:nvPicPr>
@@ -5295,6 +5435,10 @@
           </a:solidFill>
           <a:ln/>
         </p:spPr>
+        <p:txBody>
+          <a:bodyPr/>
+          <a:p/>
+        </p:txBody>
       </p:sp>
       <p:sp>
         <p:nvSpPr>
@@ -5315,6 +5459,10 @@
           </a:solidFill>
           <a:ln/>
         </p:spPr>
+        <p:txBody>
+          <a:bodyPr/>
+          <a:p/>
+        </p:txBody>
       </p:sp>
       <p:pic>
         <p:nvPicPr>
@@ -5439,6 +5587,10 @@
           </a:solidFill>
           <a:ln/>
         </p:spPr>
+        <p:txBody>
+          <a:bodyPr/>
+          <a:p/>
+        </p:txBody>
       </p:sp>
       <p:sp>
         <p:nvSpPr>
@@ -5459,6 +5611,10 @@
           </a:solidFill>
           <a:ln/>
         </p:spPr>
+        <p:txBody>
+          <a:bodyPr/>
+          <a:p/>
+        </p:txBody>
       </p:sp>
       <p:pic>
         <p:nvPicPr>
@@ -5583,6 +5739,10 @@
           </a:solidFill>
           <a:ln/>
         </p:spPr>
+        <p:txBody>
+          <a:bodyPr/>
+          <a:p/>
+        </p:txBody>
       </p:sp>
       <p:sp>
         <p:nvSpPr>
@@ -5603,6 +5763,10 @@
           </a:solidFill>
           <a:ln/>
         </p:spPr>
+        <p:txBody>
+          <a:bodyPr/>
+          <a:p/>
+        </p:txBody>
       </p:sp>
       <p:pic>
         <p:nvPicPr>
@@ -5727,6 +5891,10 @@
           </a:solidFill>
           <a:ln/>
         </p:spPr>
+        <p:txBody>
+          <a:bodyPr/>
+          <a:p/>
+        </p:txBody>
       </p:sp>
       <p:sp>
         <p:nvSpPr>
@@ -5747,6 +5915,10 @@
           </a:solidFill>
           <a:ln/>
         </p:spPr>
+        <p:txBody>
+          <a:bodyPr/>
+          <a:p/>
+        </p:txBody>
       </p:sp>
       <p:pic>
         <p:nvPicPr>
@@ -5871,6 +6043,10 @@
           </a:solidFill>
           <a:ln/>
         </p:spPr>
+        <p:txBody>
+          <a:bodyPr/>
+          <a:p/>
+        </p:txBody>
       </p:sp>
       <p:sp>
         <p:nvSpPr>
@@ -5891,6 +6067,10 @@
           </a:solidFill>
           <a:ln/>
         </p:spPr>
+        <p:txBody>
+          <a:bodyPr/>
+          <a:p/>
+        </p:txBody>
       </p:sp>
       <p:pic>
         <p:nvPicPr>
@@ -6015,6 +6195,10 @@
           </a:solidFill>
           <a:ln/>
         </p:spPr>
+        <p:txBody>
+          <a:bodyPr/>
+          <a:p/>
+        </p:txBody>
       </p:sp>
       <p:sp>
         <p:nvSpPr>
@@ -6035,6 +6219,10 @@
           </a:solidFill>
           <a:ln/>
         </p:spPr>
+        <p:txBody>
+          <a:bodyPr/>
+          <a:p/>
+        </p:txBody>
       </p:sp>
       <p:pic>
         <p:nvPicPr>
@@ -6159,6 +6347,10 @@
           </a:solidFill>
           <a:ln/>
         </p:spPr>
+        <p:txBody>
+          <a:bodyPr/>
+          <a:p/>
+        </p:txBody>
       </p:sp>
       <p:sp>
         <p:nvSpPr>
@@ -6179,6 +6371,10 @@
           </a:solidFill>
           <a:ln/>
         </p:spPr>
+        <p:txBody>
+          <a:bodyPr/>
+          <a:p/>
+        </p:txBody>
       </p:sp>
       <p:pic>
         <p:nvPicPr>
@@ -6413,6 +6609,10 @@
           </a:solidFill>
           <a:ln/>
         </p:spPr>
+        <p:txBody>
+          <a:bodyPr/>
+          <a:p/>
+        </p:txBody>
       </p:sp>
       <p:sp>
         <p:nvSpPr>
@@ -6601,6 +6801,10 @@
           </a:solidFill>
           <a:ln/>
         </p:spPr>
+        <p:txBody>
+          <a:bodyPr/>
+          <a:p/>
+        </p:txBody>
       </p:sp>
       <p:sp>
         <p:nvSpPr>
@@ -6899,6 +7103,10 @@
           </a:solidFill>
           <a:ln/>
         </p:spPr>
+        <p:txBody>
+          <a:bodyPr/>
+          <a:p/>
+        </p:txBody>
       </p:sp>
       <p:sp>
         <p:nvSpPr>
@@ -6999,6 +7207,10 @@
           </a:solidFill>
           <a:ln/>
         </p:spPr>
+        <p:txBody>
+          <a:bodyPr/>
+          <a:p/>
+        </p:txBody>
       </p:sp>
       <p:sp>
         <p:nvSpPr>
@@ -7099,6 +7311,10 @@
           </a:solidFill>
           <a:ln/>
         </p:spPr>
+        <p:txBody>
+          <a:bodyPr/>
+          <a:p/>
+        </p:txBody>
       </p:sp>
       <p:sp>
         <p:nvSpPr>
@@ -7199,6 +7415,10 @@
           </a:solidFill>
           <a:ln/>
         </p:spPr>
+        <p:txBody>
+          <a:bodyPr/>
+          <a:p/>
+        </p:txBody>
       </p:sp>
       <p:sp>
         <p:nvSpPr>
@@ -7364,7 +7584,7 @@
                 <a:ea typeface="Calibri" pitchFamily="34" charset="-122"/>
                 <a:cs typeface="Calibri" pitchFamily="34" charset="-120"/>
               </a:rPr>
-              <a:t>A documentação compartilhada é a fonte única de regras; git sincroniza os dois lados.</a:t>
+              <a:t>A documentação compartilhada é a fonte única de regras; a config de cada ambiente fica só no .env, então o git sincroniza os dois lados com um pull.</a:t>
             </a:r>
             <a:endParaRPr lang="en-US" sz="1300" dirty="0"/>
           </a:p>
@@ -7469,6 +7689,10 @@
             </a:outerShdw>
           </a:effectLst>
         </p:spPr>
+        <p:txBody>
+          <a:bodyPr/>
+          <a:p/>
+        </p:txBody>
       </p:sp>
       <p:sp>
         <p:nvSpPr>
@@ -7489,6 +7713,10 @@
           </a:solidFill>
           <a:ln/>
         </p:spPr>
+        <p:txBody>
+          <a:bodyPr/>
+          <a:p/>
+        </p:txBody>
       </p:sp>
       <p:pic>
         <p:nvPicPr>
@@ -7620,6 +7848,10 @@
             </a:outerShdw>
           </a:effectLst>
         </p:spPr>
+        <p:txBody>
+          <a:bodyPr/>
+          <a:p/>
+        </p:txBody>
       </p:sp>
       <p:sp>
         <p:nvSpPr>
@@ -7640,6 +7872,10 @@
           </a:solidFill>
           <a:ln/>
         </p:spPr>
+        <p:txBody>
+          <a:bodyPr/>
+          <a:p/>
+        </p:txBody>
       </p:sp>
       <p:pic>
         <p:nvPicPr>
@@ -7771,6 +8007,10 @@
             </a:outerShdw>
           </a:effectLst>
         </p:spPr>
+        <p:txBody>
+          <a:bodyPr/>
+          <a:p/>
+        </p:txBody>
       </p:sp>
       <p:sp>
         <p:nvSpPr>
@@ -7791,6 +8031,10 @@
           </a:solidFill>
           <a:ln/>
         </p:spPr>
+        <p:txBody>
+          <a:bodyPr/>
+          <a:p/>
+        </p:txBody>
       </p:sp>
       <p:pic>
         <p:nvPicPr>
@@ -7922,6 +8166,10 @@
             </a:outerShdw>
           </a:effectLst>
         </p:spPr>
+        <p:txBody>
+          <a:bodyPr/>
+          <a:p/>
+        </p:txBody>
       </p:sp>
       <p:sp>
         <p:nvSpPr>
@@ -7942,6 +8190,10 @@
           </a:solidFill>
           <a:ln/>
         </p:spPr>
+        <p:txBody>
+          <a:bodyPr/>
+          <a:p/>
+        </p:txBody>
       </p:sp>
       <p:pic>
         <p:nvPicPr>
@@ -8073,6 +8325,10 @@
             </a:outerShdw>
           </a:effectLst>
         </p:spPr>
+        <p:txBody>
+          <a:bodyPr/>
+          <a:p/>
+        </p:txBody>
       </p:sp>
       <p:sp>
         <p:nvSpPr>
@@ -8093,6 +8349,10 @@
           </a:solidFill>
           <a:ln/>
         </p:spPr>
+        <p:txBody>
+          <a:bodyPr/>
+          <a:p/>
+        </p:txBody>
       </p:sp>
       <p:pic>
         <p:nvPicPr>
@@ -8224,6 +8484,10 @@
             </a:outerShdw>
           </a:effectLst>
         </p:spPr>
+        <p:txBody>
+          <a:bodyPr/>
+          <a:p/>
+        </p:txBody>
       </p:sp>
       <p:sp>
         <p:nvSpPr>
@@ -8244,6 +8508,10 @@
           </a:solidFill>
           <a:ln/>
         </p:spPr>
+        <p:txBody>
+          <a:bodyPr/>
+          <a:p/>
+        </p:txBody>
       </p:sp>
       <p:pic>
         <p:nvPicPr>
@@ -8341,7 +8609,7 @@
                 <a:ea typeface="Calibri" pitchFamily="34" charset="-122"/>
                 <a:cs typeface="Calibri" pitchFamily="34" charset="-120"/>
               </a:rPr>
-              <a:t>Licença de uso claro, formulário de feedback e processo de melhoria contínua</a:t>
+              <a:t>Open-source sob Licença MIT, com créditos a ideias externas adotadas e processo de melhoria contínua</a:t>
             </a:r>
             <a:endParaRPr lang="en-US" sz="1150" dirty="0"/>
           </a:p>
@@ -8437,6 +8705,10 @@
           </a:solidFill>
           <a:ln/>
         </p:spPr>
+        <p:txBody>
+          <a:bodyPr/>
+          <a:p/>
+        </p:txBody>
       </p:sp>
       <p:sp>
         <p:nvSpPr>
@@ -8574,6 +8846,10 @@
           </a:solidFill>
           <a:ln/>
         </p:spPr>
+        <p:txBody>
+          <a:bodyPr/>
+          <a:p/>
+        </p:txBody>
       </p:sp>
       <p:sp>
         <p:nvSpPr>
@@ -8711,6 +8987,10 @@
           </a:solidFill>
           <a:ln/>
         </p:spPr>
+        <p:txBody>
+          <a:bodyPr/>
+          <a:p/>
+        </p:txBody>
       </p:sp>
       <p:sp>
         <p:nvSpPr>
@@ -8850,6 +9130,10 @@
           </a:solidFill>
           <a:ln/>
         </p:spPr>
+        <p:txBody>
+          <a:bodyPr/>
+          <a:p/>
+        </p:txBody>
       </p:sp>
       <p:sp>
         <p:nvSpPr>

</xml_diff>

<commit_message>
docs(kit): slide de relatorios + destaque da apresentacao no README
- Apresentacao: slide 6 novo "Os relatorios que a IA devolve"
  (ESTADO-ATUAL, progresso, plano, verificacao/TWINS) no padrao visual;
  frase final -> "ela fica ainda mais confiavel" (tom positivo)
- README: secao "Apresentacao" no topo com capa clicavel (docs/img/capa.png)
  + slide de relatorios como preview; link de download do PPTX
- fix: atualizar-apresentacao.py salvava so quando nao havia substituicao
  pendente (sys.exit antes do save) -> corrigido; itens ja aplicados viram
  comentario
- novo: tools/adicionar-slide-relatorios.py (gera o slide, idempotente)

Verificado por observacao: PNGs conferidos e slide 6 renderiza no padrao.

Co-Authored-By: Claude Opus 4.8 <noreply@anthropic.com>
</commit_message>
<xml_diff>
--- a/Apresentacao-Metodo-Norte.pptx
+++ b/Apresentacao-Metodo-Norte.pptx
@@ -10,6 +10,7 @@
     <p:sldId id="258" r:id="rId4"/>
     <p:sldId id="259" r:id="rId5"/>
     <p:sldId id="260" r:id="rId6"/>
+    <p:sldId id="267" r:id="rId18"/>
     <p:sldId id="261" r:id="rId7"/>
     <p:sldId id="262" r:id="rId8"/>
     <p:sldId id="263" r:id="rId9"/>
@@ -2091,6 +2092,593 @@
 
 <file path=ppt/slides/slide10.xml><?xml version="1.0" encoding="utf-8"?>
 <p:sld xmlns:a="http://schemas.openxmlformats.org/drawingml/2006/main" xmlns:r="http://schemas.openxmlformats.org/officeDocument/2006/relationships" xmlns:p="http://schemas.openxmlformats.org/presentationml/2006/main">
+  <p:cSld name="Slide 9">
+    <p:bg>
+      <p:bgPr>
+        <a:solidFill>
+          <a:srgbClr val="FFFFFF"/>
+        </a:solidFill>
+      </p:bgPr>
+    </p:bg>
+    <p:spTree>
+      <p:nvGrpSpPr>
+        <p:cNvPr id="1" name=""/>
+        <p:cNvGrpSpPr/>
+        <p:nvPr/>
+      </p:nvGrpSpPr>
+      <p:grpSpPr>
+        <a:xfrm>
+          <a:off x="0" y="0"/>
+          <a:ext cx="0" cy="0"/>
+          <a:chOff x="0" y="0"/>
+          <a:chExt cx="0" cy="0"/>
+        </a:xfrm>
+      </p:grpSpPr>
+      <p:sp>
+        <p:nvSpPr>
+          <p:cNvPr id="2" name="Text 0"/>
+          <p:cNvSpPr/>
+          <p:nvPr/>
+        </p:nvSpPr>
+        <p:spPr>
+          <a:xfrm>
+            <a:off x="640080" y="502920"/>
+            <a:ext cx="10972800" cy="731520"/>
+          </a:xfrm>
+          <a:prstGeom prst="rect">
+            <a:avLst/>
+          </a:prstGeom>
+          <a:noFill/>
+          <a:ln/>
+        </p:spPr>
+        <p:txBody>
+          <a:bodyPr wrap="square" lIns="0" tIns="0" rIns="0" bIns="0" rtlCol="0" anchor="ctr"/>
+          <a:lstStyle/>
+          <a:p>
+            <a:pPr indent="0" marL="0">
+              <a:buNone/>
+            </a:pPr>
+            <a:r>
+              <a:rPr lang="en-US" sz="3800" b="1" dirty="0">
+                <a:solidFill>
+                  <a:srgbClr val="1E2761"/>
+                </a:solidFill>
+                <a:latin typeface="Cambria" pitchFamily="34" charset="0"/>
+                <a:ea typeface="Cambria" pitchFamily="34" charset="-122"/>
+                <a:cs typeface="Cambria" pitchFamily="34" charset="-120"/>
+              </a:rPr>
+              <a:t>Implantação em 3 passos</a:t>
+            </a:r>
+            <a:endParaRPr lang="en-US" sz="3800" dirty="0"/>
+          </a:p>
+        </p:txBody>
+      </p:sp>
+      <p:sp>
+        <p:nvSpPr>
+          <p:cNvPr id="3" name="Shape 1"/>
+          <p:cNvSpPr/>
+          <p:nvPr/>
+        </p:nvSpPr>
+        <p:spPr>
+          <a:xfrm>
+            <a:off x="822960" y="1828800"/>
+            <a:ext cx="914400" cy="914400"/>
+          </a:xfrm>
+          <a:prstGeom prst="ellipse">
+            <a:avLst/>
+          </a:prstGeom>
+          <a:solidFill>
+            <a:srgbClr val="1E2761"/>
+          </a:solidFill>
+          <a:ln/>
+        </p:spPr>
+        <p:txBody>
+          <a:bodyPr/>
+          <a:p/>
+        </p:txBody>
+      </p:sp>
+      <p:sp>
+        <p:nvSpPr>
+          <p:cNvPr id="4" name="Text 2"/>
+          <p:cNvSpPr/>
+          <p:nvPr/>
+        </p:nvSpPr>
+        <p:spPr>
+          <a:xfrm>
+            <a:off x="822960" y="1828800"/>
+            <a:ext cx="914400" cy="914400"/>
+          </a:xfrm>
+          <a:prstGeom prst="rect">
+            <a:avLst/>
+          </a:prstGeom>
+          <a:noFill/>
+          <a:ln/>
+        </p:spPr>
+        <p:txBody>
+          <a:bodyPr wrap="square" lIns="0" tIns="0" rIns="0" bIns="0" rtlCol="0" anchor="ctr"/>
+          <a:lstStyle/>
+          <a:p>
+            <a:pPr algn="ctr" indent="0" marL="0">
+              <a:buNone/>
+            </a:pPr>
+            <a:r>
+              <a:rPr lang="en-US" sz="3000" b="1" dirty="0">
+                <a:solidFill>
+                  <a:srgbClr val="F0B429"/>
+                </a:solidFill>
+                <a:latin typeface="Cambria" pitchFamily="34" charset="0"/>
+                <a:ea typeface="Cambria" pitchFamily="34" charset="-122"/>
+                <a:cs typeface="Cambria" pitchFamily="34" charset="-120"/>
+              </a:rPr>
+              <a:t>1</a:t>
+            </a:r>
+            <a:endParaRPr lang="en-US" sz="3000" dirty="0"/>
+          </a:p>
+        </p:txBody>
+      </p:sp>
+      <p:sp>
+        <p:nvSpPr>
+          <p:cNvPr id="5" name="Text 3"/>
+          <p:cNvSpPr/>
+          <p:nvPr/>
+        </p:nvSpPr>
+        <p:spPr>
+          <a:xfrm>
+            <a:off x="2057400" y="1737360"/>
+            <a:ext cx="2011680" cy="548640"/>
+          </a:xfrm>
+          <a:prstGeom prst="rect">
+            <a:avLst/>
+          </a:prstGeom>
+          <a:noFill/>
+          <a:ln/>
+        </p:spPr>
+        <p:txBody>
+          <a:bodyPr wrap="square" lIns="0" tIns="0" rIns="0" bIns="0" rtlCol="0" anchor="ctr"/>
+          <a:lstStyle/>
+          <a:p>
+            <a:pPr indent="0" marL="0">
+              <a:buNone/>
+            </a:pPr>
+            <a:r>
+              <a:rPr lang="en-US" sz="2000" b="1" dirty="0">
+                <a:solidFill>
+                  <a:srgbClr val="1E2761"/>
+                </a:solidFill>
+                <a:latin typeface="Calibri" pitchFamily="34" charset="0"/>
+                <a:ea typeface="Calibri" pitchFamily="34" charset="-122"/>
+                <a:cs typeface="Calibri" pitchFamily="34" charset="-120"/>
+              </a:rPr>
+              <a:t>Copie</a:t>
+            </a:r>
+            <a:endParaRPr lang="en-US" sz="2000" dirty="0"/>
+          </a:p>
+        </p:txBody>
+      </p:sp>
+      <p:sp>
+        <p:nvSpPr>
+          <p:cNvPr id="6" name="Text 4"/>
+          <p:cNvSpPr/>
+          <p:nvPr/>
+        </p:nvSpPr>
+        <p:spPr>
+          <a:xfrm>
+            <a:off x="2057400" y="2240280"/>
+            <a:ext cx="8961120" cy="731520"/>
+          </a:xfrm>
+          <a:prstGeom prst="rect">
+            <a:avLst/>
+          </a:prstGeom>
+          <a:noFill/>
+          <a:ln/>
+        </p:spPr>
+        <p:txBody>
+          <a:bodyPr wrap="square" lIns="0" tIns="0" rIns="0" bIns="0" rtlCol="0" anchor="ctr"/>
+          <a:lstStyle/>
+          <a:p>
+            <a:pPr indent="0" marL="0">
+              <a:buNone/>
+            </a:pPr>
+            <a:r>
+              <a:rPr lang="en-US" sz="1450" dirty="0">
+                <a:solidFill>
+                  <a:srgbClr val="5A6B8C"/>
+                </a:solidFill>
+                <a:latin typeface="Calibri" pitchFamily="34" charset="0"/>
+                <a:ea typeface="Calibri" pitchFamily="34" charset="-122"/>
+                <a:cs typeface="Calibri" pitchFamily="34" charset="-120"/>
+              </a:rPr>
+              <a:t>Copie a pasta template para onde sua documentação vai morar e renomeie.</a:t>
+            </a:r>
+            <a:endParaRPr lang="en-US" sz="1450" dirty="0"/>
+          </a:p>
+        </p:txBody>
+      </p:sp>
+      <p:sp>
+        <p:nvSpPr>
+          <p:cNvPr id="7" name="Shape 5"/>
+          <p:cNvSpPr/>
+          <p:nvPr/>
+        </p:nvSpPr>
+        <p:spPr>
+          <a:xfrm>
+            <a:off x="822960" y="3246120"/>
+            <a:ext cx="914400" cy="914400"/>
+          </a:xfrm>
+          <a:prstGeom prst="ellipse">
+            <a:avLst/>
+          </a:prstGeom>
+          <a:solidFill>
+            <a:srgbClr val="1E2761"/>
+          </a:solidFill>
+          <a:ln/>
+        </p:spPr>
+        <p:txBody>
+          <a:bodyPr/>
+          <a:p/>
+        </p:txBody>
+      </p:sp>
+      <p:sp>
+        <p:nvSpPr>
+          <p:cNvPr id="8" name="Text 6"/>
+          <p:cNvSpPr/>
+          <p:nvPr/>
+        </p:nvSpPr>
+        <p:spPr>
+          <a:xfrm>
+            <a:off x="822960" y="3246120"/>
+            <a:ext cx="914400" cy="914400"/>
+          </a:xfrm>
+          <a:prstGeom prst="rect">
+            <a:avLst/>
+          </a:prstGeom>
+          <a:noFill/>
+          <a:ln/>
+        </p:spPr>
+        <p:txBody>
+          <a:bodyPr wrap="square" lIns="0" tIns="0" rIns="0" bIns="0" rtlCol="0" anchor="ctr"/>
+          <a:lstStyle/>
+          <a:p>
+            <a:pPr algn="ctr" indent="0" marL="0">
+              <a:buNone/>
+            </a:pPr>
+            <a:r>
+              <a:rPr lang="en-US" sz="3000" b="1" dirty="0">
+                <a:solidFill>
+                  <a:srgbClr val="F0B429"/>
+                </a:solidFill>
+                <a:latin typeface="Cambria" pitchFamily="34" charset="0"/>
+                <a:ea typeface="Cambria" pitchFamily="34" charset="-122"/>
+                <a:cs typeface="Cambria" pitchFamily="34" charset="-120"/>
+              </a:rPr>
+              <a:t>2</a:t>
+            </a:r>
+            <a:endParaRPr lang="en-US" sz="3000" dirty="0"/>
+          </a:p>
+        </p:txBody>
+      </p:sp>
+      <p:sp>
+        <p:nvSpPr>
+          <p:cNvPr id="9" name="Text 7"/>
+          <p:cNvSpPr/>
+          <p:nvPr/>
+        </p:nvSpPr>
+        <p:spPr>
+          <a:xfrm>
+            <a:off x="2057400" y="3154680"/>
+            <a:ext cx="2011680" cy="548640"/>
+          </a:xfrm>
+          <a:prstGeom prst="rect">
+            <a:avLst/>
+          </a:prstGeom>
+          <a:noFill/>
+          <a:ln/>
+        </p:spPr>
+        <p:txBody>
+          <a:bodyPr wrap="square" lIns="0" tIns="0" rIns="0" bIns="0" rtlCol="0" anchor="ctr"/>
+          <a:lstStyle/>
+          <a:p>
+            <a:pPr indent="0" marL="0">
+              <a:buNone/>
+            </a:pPr>
+            <a:r>
+              <a:rPr lang="en-US" sz="2000" b="1" dirty="0">
+                <a:solidFill>
+                  <a:srgbClr val="1E2761"/>
+                </a:solidFill>
+                <a:latin typeface="Calibri" pitchFamily="34" charset="0"/>
+                <a:ea typeface="Calibri" pitchFamily="34" charset="-122"/>
+                <a:cs typeface="Calibri" pitchFamily="34" charset="-120"/>
+              </a:rPr>
+              <a:t>Responda</a:t>
+            </a:r>
+            <a:endParaRPr lang="en-US" sz="2000" dirty="0"/>
+          </a:p>
+        </p:txBody>
+      </p:sp>
+      <p:sp>
+        <p:nvSpPr>
+          <p:cNvPr id="10" name="Text 8"/>
+          <p:cNvSpPr/>
+          <p:nvPr/>
+        </p:nvSpPr>
+        <p:spPr>
+          <a:xfrm>
+            <a:off x="2057400" y="3657600"/>
+            <a:ext cx="8961120" cy="731520"/>
+          </a:xfrm>
+          <a:prstGeom prst="rect">
+            <a:avLst/>
+          </a:prstGeom>
+          <a:noFill/>
+          <a:ln/>
+        </p:spPr>
+        <p:txBody>
+          <a:bodyPr wrap="square" lIns="0" tIns="0" rIns="0" bIns="0" rtlCol="0" anchor="ctr"/>
+          <a:lstStyle/>
+          <a:p>
+            <a:pPr indent="0" marL="0">
+              <a:buNone/>
+            </a:pPr>
+            <a:r>
+              <a:rPr lang="en-US" sz="1450" dirty="0">
+                <a:solidFill>
+                  <a:srgbClr val="5A6B8C"/>
+                </a:solidFill>
+                <a:latin typeface="Calibri" pitchFamily="34" charset="0"/>
+                <a:ea typeface="Calibri" pitchFamily="34" charset="-122"/>
+                <a:cs typeface="Calibri" pitchFamily="34" charset="-120"/>
+              </a:rPr>
+              <a:t>Cole o prompt de setup na sua IA e responda ao questionário — ela preenche tudo e roda o validador até 0 erros.</a:t>
+            </a:r>
+            <a:endParaRPr lang="en-US" sz="1450" dirty="0"/>
+          </a:p>
+        </p:txBody>
+      </p:sp>
+      <p:sp>
+        <p:nvSpPr>
+          <p:cNvPr id="11" name="Shape 9"/>
+          <p:cNvSpPr/>
+          <p:nvPr/>
+        </p:nvSpPr>
+        <p:spPr>
+          <a:xfrm>
+            <a:off x="822960" y="4663440"/>
+            <a:ext cx="914400" cy="914400"/>
+          </a:xfrm>
+          <a:prstGeom prst="ellipse">
+            <a:avLst/>
+          </a:prstGeom>
+          <a:solidFill>
+            <a:srgbClr val="1E2761"/>
+          </a:solidFill>
+          <a:ln/>
+        </p:spPr>
+        <p:txBody>
+          <a:bodyPr/>
+          <a:p/>
+        </p:txBody>
+      </p:sp>
+      <p:sp>
+        <p:nvSpPr>
+          <p:cNvPr id="12" name="Text 10"/>
+          <p:cNvSpPr/>
+          <p:nvPr/>
+        </p:nvSpPr>
+        <p:spPr>
+          <a:xfrm>
+            <a:off x="822960" y="4663440"/>
+            <a:ext cx="914400" cy="914400"/>
+          </a:xfrm>
+          <a:prstGeom prst="rect">
+            <a:avLst/>
+          </a:prstGeom>
+          <a:noFill/>
+          <a:ln/>
+        </p:spPr>
+        <p:txBody>
+          <a:bodyPr wrap="square" lIns="0" tIns="0" rIns="0" bIns="0" rtlCol="0" anchor="ctr"/>
+          <a:lstStyle/>
+          <a:p>
+            <a:pPr algn="ctr" indent="0" marL="0">
+              <a:buNone/>
+            </a:pPr>
+            <a:r>
+              <a:rPr lang="en-US" sz="3000" b="1" dirty="0">
+                <a:solidFill>
+                  <a:srgbClr val="F0B429"/>
+                </a:solidFill>
+                <a:latin typeface="Cambria" pitchFamily="34" charset="0"/>
+                <a:ea typeface="Cambria" pitchFamily="34" charset="-122"/>
+                <a:cs typeface="Cambria" pitchFamily="34" charset="-120"/>
+              </a:rPr>
+              <a:t>3</a:t>
+            </a:r>
+            <a:endParaRPr lang="en-US" sz="3000" dirty="0"/>
+          </a:p>
+        </p:txBody>
+      </p:sp>
+      <p:sp>
+        <p:nvSpPr>
+          <p:cNvPr id="13" name="Text 11"/>
+          <p:cNvSpPr/>
+          <p:nvPr/>
+        </p:nvSpPr>
+        <p:spPr>
+          <a:xfrm>
+            <a:off x="2057400" y="4572000"/>
+            <a:ext cx="2011680" cy="548640"/>
+          </a:xfrm>
+          <a:prstGeom prst="rect">
+            <a:avLst/>
+          </a:prstGeom>
+          <a:noFill/>
+          <a:ln/>
+        </p:spPr>
+        <p:txBody>
+          <a:bodyPr wrap="square" lIns="0" tIns="0" rIns="0" bIns="0" rtlCol="0" anchor="ctr"/>
+          <a:lstStyle/>
+          <a:p>
+            <a:pPr indent="0" marL="0">
+              <a:buNone/>
+            </a:pPr>
+            <a:r>
+              <a:rPr lang="en-US" sz="2000" b="1" dirty="0">
+                <a:solidFill>
+                  <a:srgbClr val="1E2761"/>
+                </a:solidFill>
+                <a:latin typeface="Calibri" pitchFamily="34" charset="0"/>
+                <a:ea typeface="Calibri" pitchFamily="34" charset="-122"/>
+                <a:cs typeface="Calibri" pitchFamily="34" charset="-120"/>
+              </a:rPr>
+              <a:t>Aponte</a:t>
+            </a:r>
+            <a:endParaRPr lang="en-US" sz="2000" dirty="0"/>
+          </a:p>
+        </p:txBody>
+      </p:sp>
+      <p:sp>
+        <p:nvSpPr>
+          <p:cNvPr id="14" name="Text 12"/>
+          <p:cNvSpPr/>
+          <p:nvPr/>
+        </p:nvSpPr>
+        <p:spPr>
+          <a:xfrm>
+            <a:off x="2057400" y="5074920"/>
+            <a:ext cx="8961120" cy="731520"/>
+          </a:xfrm>
+          <a:prstGeom prst="rect">
+            <a:avLst/>
+          </a:prstGeom>
+          <a:noFill/>
+          <a:ln/>
+        </p:spPr>
+        <p:txBody>
+          <a:bodyPr wrap="square" lIns="0" tIns="0" rIns="0" bIns="0" rtlCol="0" anchor="ctr"/>
+          <a:lstStyle/>
+          <a:p>
+            <a:pPr indent="0" marL="0">
+              <a:buNone/>
+            </a:pPr>
+            <a:r>
+              <a:rPr lang="en-US" sz="1450" dirty="0">
+                <a:solidFill>
+                  <a:srgbClr val="5A6B8C"/>
+                </a:solidFill>
+                <a:latin typeface="Calibri" pitchFamily="34" charset="0"/>
+                <a:ea typeface="Calibri" pitchFamily="34" charset="-122"/>
+                <a:cs typeface="Calibri" pitchFamily="34" charset="-120"/>
+              </a:rPr>
+              <a:t>Referencie o hub no arquivo de instruções de cada projeto. Pronto: toda sessão de IA começa com o norte certo.</a:t>
+            </a:r>
+            <a:endParaRPr lang="en-US" sz="1450" dirty="0"/>
+          </a:p>
+        </p:txBody>
+      </p:sp>
+      <p:sp>
+        <p:nvSpPr>
+          <p:cNvPr id="15" name="Shape 13"/>
+          <p:cNvSpPr/>
+          <p:nvPr/>
+        </p:nvSpPr>
+        <p:spPr>
+          <a:xfrm>
+            <a:off x="640080" y="5897880"/>
+            <a:ext cx="10881360" cy="685800"/>
+          </a:xfrm>
+          <a:prstGeom prst="roundRect">
+            <a:avLst>
+              <a:gd name="adj" fmla="val 13333"/>
+            </a:avLst>
+          </a:prstGeom>
+          <a:solidFill>
+            <a:srgbClr val="EFF4FC"/>
+          </a:solidFill>
+          <a:ln/>
+        </p:spPr>
+        <p:txBody>
+          <a:bodyPr/>
+          <a:p/>
+        </p:txBody>
+      </p:sp>
+      <p:sp>
+        <p:nvSpPr>
+          <p:cNvPr id="16" name="Text 14"/>
+          <p:cNvSpPr/>
+          <p:nvPr/>
+        </p:nvSpPr>
+        <p:spPr>
+          <a:xfrm>
+            <a:off x="914400" y="5897880"/>
+            <a:ext cx="10332720" cy="685800"/>
+          </a:xfrm>
+          <a:prstGeom prst="rect">
+            <a:avLst/>
+          </a:prstGeom>
+          <a:noFill/>
+          <a:ln/>
+        </p:spPr>
+        <p:txBody>
+          <a:bodyPr wrap="square" lIns="0" tIns="0" rIns="0" bIns="0" rtlCol="0" anchor="ctr"/>
+          <a:lstStyle/>
+          <a:p>
+            <a:pPr algn="ctr" indent="0" marL="0">
+              <a:buNone/>
+            </a:pPr>
+            <a:r>
+              <a:rPr lang="en-US" sz="1400" dirty="0">
+                <a:solidFill>
+                  <a:srgbClr val="5A6B8C"/>
+                </a:solidFill>
+                <a:latin typeface="Calibri" pitchFamily="34" charset="0"/>
+                <a:ea typeface="Calibri" pitchFamily="34" charset="-122"/>
+                <a:cs typeface="Calibri" pitchFamily="34" charset="-120"/>
+              </a:rPr>
+              <a:t>Tempo típico até a primeira versão útil: </a:t>
+            </a:r>
+            <a:pPr algn="ctr" indent="0" marL="0">
+              <a:buNone/>
+            </a:pPr>
+            <a:r>
+              <a:rPr lang="en-US" sz="1400" b="1" dirty="0">
+                <a:solidFill>
+                  <a:srgbClr val="1E2761"/>
+                </a:solidFill>
+                <a:latin typeface="Calibri" pitchFamily="34" charset="0"/>
+                <a:ea typeface="Calibri" pitchFamily="34" charset="-122"/>
+                <a:cs typeface="Calibri" pitchFamily="34" charset="-120"/>
+              </a:rPr>
+              <a:t>1 a 2 horas</a:t>
+            </a:r>
+            <a:pPr algn="ctr" indent="0" marL="0">
+              <a:buNone/>
+            </a:pPr>
+            <a:r>
+              <a:rPr lang="en-US" sz="1400" dirty="0">
+                <a:solidFill>
+                  <a:srgbClr val="5A6B8C"/>
+                </a:solidFill>
+                <a:latin typeface="Calibri" pitchFamily="34" charset="0"/>
+                <a:ea typeface="Calibri" pitchFamily="34" charset="-122"/>
+                <a:cs typeface="Calibri" pitchFamily="34" charset="-120"/>
+              </a:rPr>
+              <a:t>  ·  funciona com Claude Code, Cursor, Copilot e afins</a:t>
+            </a:r>
+            <a:endParaRPr lang="en-US" sz="1400" dirty="0"/>
+          </a:p>
+        </p:txBody>
+      </p:sp>
+    </p:spTree>
+  </p:cSld>
+  <p:clrMapOvr>
+    <a:masterClrMapping/>
+  </p:clrMapOvr>
+</p:sld>
+</file>
+
+<file path=ppt/slides/slide11.xml><?xml version="1.0" encoding="utf-8"?>
+<p:sld xmlns:a="http://schemas.openxmlformats.org/drawingml/2006/main" xmlns:r="http://schemas.openxmlformats.org/officeDocument/2006/relationships" xmlns:p="http://schemas.openxmlformats.org/presentationml/2006/main">
   <p:cSld name="Slide 10">
     <p:bg>
       <p:bgPr>
@@ -2676,7 +3264,7 @@
 </p:sld>
 </file>
 
-<file path=ppt/slides/slide11.xml><?xml version="1.0" encoding="utf-8"?>
+<file path=ppt/slides/slide12.xml><?xml version="1.0" encoding="utf-8"?>
 <p:sld xmlns:a="http://schemas.openxmlformats.org/drawingml/2006/main" xmlns:r="http://schemas.openxmlformats.org/officeDocument/2006/relationships" xmlns:p="http://schemas.openxmlformats.org/presentationml/2006/main">
   <p:cSld name="Slide 11">
     <p:bg>
@@ -2848,7 +3436,7 @@
                 <a:ea typeface="Calibri" pitchFamily="34" charset="-122"/>
                 <a:cs typeface="Calibri" pitchFamily="34" charset="-120"/>
               </a:rPr>
-              <a:t>A IA já é rápida. Com o Método Norte, ela passa a ser confiável.</a:t>
+              <a:t>A IA já é rápida. Com o Método Norte, ela fica ainda mais confiável.</a:t>
             </a:r>
             <a:endParaRPr lang="en-US" sz="2000" dirty="0"/>
           </a:p>
@@ -6487,6 +7075,558 @@
 </file>
 
 <file path=ppt/slides/slide6.xml><?xml version="1.0" encoding="utf-8"?>
+<p:sld xmlns:a="http://schemas.openxmlformats.org/drawingml/2006/main" xmlns:p="http://schemas.openxmlformats.org/presentationml/2006/main" xmlns:r="http://schemas.openxmlformats.org/officeDocument/2006/relationships">
+  <p:cSld>
+    <p:bg>
+      <p:bgPr>
+        <a:solidFill>
+          <a:srgbClr val="1E2761"/>
+        </a:solidFill>
+        <a:effectLst/>
+      </p:bgPr>
+    </p:bg>
+    <p:spTree>
+      <p:nvGrpSpPr>
+        <p:cNvPr id="1" name=""/>
+        <p:cNvGrpSpPr/>
+        <p:nvPr/>
+      </p:nvGrpSpPr>
+      <p:grpSpPr/>
+      <p:sp>
+        <p:nvSpPr>
+          <p:cNvPr id="2" name="TextBox 1"/>
+          <p:cNvSpPr txBox="1"/>
+          <p:nvPr/>
+        </p:nvSpPr>
+        <p:spPr>
+          <a:xfrm>
+            <a:off x="640080" y="457200"/>
+            <a:ext cx="10972800" cy="822960"/>
+          </a:xfrm>
+          <a:prstGeom prst="rect">
+            <a:avLst/>
+          </a:prstGeom>
+          <a:noFill/>
+        </p:spPr>
+        <p:txBody>
+          <a:bodyPr wrap="square">
+            <a:spAutoFit/>
+          </a:bodyPr>
+          <a:lstStyle/>
+          <a:p>
+            <a:pPr algn="l"/>
+            <a:r>
+              <a:rPr sz="3400" b="1">
+                <a:solidFill>
+                  <a:srgbClr val="FFFFFF"/>
+                </a:solidFill>
+                <a:latin typeface="Cambria"/>
+              </a:rPr>
+              <a:t>Os relatórios que a IA devolve</a:t>
+            </a:r>
+          </a:p>
+        </p:txBody>
+      </p:sp>
+      <p:sp>
+        <p:nvSpPr>
+          <p:cNvPr id="3" name="TextBox 2"/>
+          <p:cNvSpPr txBox="1"/>
+          <p:nvPr/>
+        </p:nvSpPr>
+        <p:spPr>
+          <a:xfrm>
+            <a:off x="640080" y="1143000"/>
+            <a:ext cx="10972800" cy="457200"/>
+          </a:xfrm>
+          <a:prstGeom prst="rect">
+            <a:avLst/>
+          </a:prstGeom>
+          <a:noFill/>
+        </p:spPr>
+        <p:txBody>
+          <a:bodyPr wrap="square">
+            <a:spAutoFit/>
+          </a:bodyPr>
+          <a:lstStyle/>
+          <a:p>
+            <a:pPr algn="l"/>
+            <a:r>
+              <a:rPr sz="1400" b="0">
+                <a:solidFill>
+                  <a:srgbClr val="CADCFC"/>
+                </a:solidFill>
+                <a:latin typeface="Calibri"/>
+              </a:rPr>
+              <a:t>A documentação não é estática: ela relata. Rastreabilidade do início ao fim de cada tarefa.</a:t>
+            </a:r>
+          </a:p>
+        </p:txBody>
+      </p:sp>
+      <p:sp>
+        <p:nvSpPr>
+          <p:cNvPr id="4" name="Rectangle 3"/>
+          <p:cNvSpPr/>
+          <p:nvPr/>
+        </p:nvSpPr>
+        <p:spPr>
+          <a:xfrm>
+            <a:off x="640080" y="1737360"/>
+            <a:ext cx="2606040" cy="3977639"/>
+          </a:xfrm>
+          <a:prstGeom prst="rect">
+            <a:avLst/>
+          </a:prstGeom>
+          <a:solidFill>
+            <a:srgbClr val="27336F"/>
+          </a:solidFill>
+          <a:ln>
+            <a:noFill/>
+          </a:ln>
+          <a:effectLst/>
+        </p:spPr>
+        <p:style>
+          <a:lnRef idx="1">
+            <a:schemeClr val="accent1"/>
+          </a:lnRef>
+          <a:fillRef idx="3">
+            <a:schemeClr val="accent1"/>
+          </a:fillRef>
+          <a:effectRef idx="2">
+            <a:schemeClr val="accent1"/>
+          </a:effectRef>
+          <a:fontRef idx="minor">
+            <a:schemeClr val="lt1"/>
+          </a:fontRef>
+        </p:style>
+        <p:txBody>
+          <a:bodyPr rtlCol="0" anchor="ctr"/>
+          <a:lstStyle/>
+          <a:p>
+            <a:pPr algn="ctr"/>
+          </a:p>
+        </p:txBody>
+      </p:sp>
+      <p:sp>
+        <p:nvSpPr>
+          <p:cNvPr id="5" name="TextBox 4"/>
+          <p:cNvSpPr txBox="1"/>
+          <p:nvPr/>
+        </p:nvSpPr>
+        <p:spPr>
+          <a:xfrm>
+            <a:off x="777240" y="1965960"/>
+            <a:ext cx="2331720" cy="548640"/>
+          </a:xfrm>
+          <a:prstGeom prst="rect">
+            <a:avLst/>
+          </a:prstGeom>
+          <a:noFill/>
+        </p:spPr>
+        <p:txBody>
+          <a:bodyPr wrap="square">
+            <a:spAutoFit/>
+          </a:bodyPr>
+          <a:lstStyle/>
+          <a:p>
+            <a:pPr algn="l"/>
+            <a:r>
+              <a:rPr sz="1500" b="1">
+                <a:solidFill>
+                  <a:srgbClr val="F0B429"/>
+                </a:solidFill>
+                <a:latin typeface="Calibri"/>
+              </a:rPr>
+              <a:t>ESTADO-ATUAL</a:t>
+            </a:r>
+          </a:p>
+        </p:txBody>
+      </p:sp>
+      <p:sp>
+        <p:nvSpPr>
+          <p:cNvPr id="6" name="TextBox 5"/>
+          <p:cNvSpPr txBox="1"/>
+          <p:nvPr/>
+        </p:nvSpPr>
+        <p:spPr>
+          <a:xfrm>
+            <a:off x="777240" y="2606039"/>
+            <a:ext cx="2331720" cy="2971799"/>
+          </a:xfrm>
+          <a:prstGeom prst="rect">
+            <a:avLst/>
+          </a:prstGeom>
+          <a:noFill/>
+        </p:spPr>
+        <p:txBody>
+          <a:bodyPr wrap="square">
+            <a:spAutoFit/>
+          </a:bodyPr>
+          <a:lstStyle/>
+          <a:p>
+            <a:pPr algn="l"/>
+            <a:r>
+              <a:rPr sz="1150" b="0">
+                <a:solidFill>
+                  <a:srgbClr val="CADCFC"/>
+                </a:solidFill>
+                <a:latin typeface="Calibri"/>
+              </a:rPr>
+              <a:t>Onde o projeto está agora e o que falta — as pendências abertas, segurança em destaque. O relatório de 1 página que a IA lê e reporta ao abrir a sessão.</a:t>
+            </a:r>
+          </a:p>
+        </p:txBody>
+      </p:sp>
+      <p:sp>
+        <p:nvSpPr>
+          <p:cNvPr id="7" name="Rectangle 6"/>
+          <p:cNvSpPr/>
+          <p:nvPr/>
+        </p:nvSpPr>
+        <p:spPr>
+          <a:xfrm>
+            <a:off x="3429000" y="1737360"/>
+            <a:ext cx="2606040" cy="3977639"/>
+          </a:xfrm>
+          <a:prstGeom prst="rect">
+            <a:avLst/>
+          </a:prstGeom>
+          <a:solidFill>
+            <a:srgbClr val="27336F"/>
+          </a:solidFill>
+          <a:ln>
+            <a:noFill/>
+          </a:ln>
+          <a:effectLst/>
+        </p:spPr>
+        <p:style>
+          <a:lnRef idx="1">
+            <a:schemeClr val="accent1"/>
+          </a:lnRef>
+          <a:fillRef idx="3">
+            <a:schemeClr val="accent1"/>
+          </a:fillRef>
+          <a:effectRef idx="2">
+            <a:schemeClr val="accent1"/>
+          </a:effectRef>
+          <a:fontRef idx="minor">
+            <a:schemeClr val="lt1"/>
+          </a:fontRef>
+        </p:style>
+        <p:txBody>
+          <a:bodyPr rtlCol="0" anchor="ctr"/>
+          <a:lstStyle/>
+          <a:p>
+            <a:pPr algn="ctr"/>
+          </a:p>
+        </p:txBody>
+      </p:sp>
+      <p:sp>
+        <p:nvSpPr>
+          <p:cNvPr id="8" name="TextBox 7"/>
+          <p:cNvSpPr txBox="1"/>
+          <p:nvPr/>
+        </p:nvSpPr>
+        <p:spPr>
+          <a:xfrm>
+            <a:off x="3566160" y="1965960"/>
+            <a:ext cx="2331720" cy="548640"/>
+          </a:xfrm>
+          <a:prstGeom prst="rect">
+            <a:avLst/>
+          </a:prstGeom>
+          <a:noFill/>
+        </p:spPr>
+        <p:txBody>
+          <a:bodyPr wrap="square">
+            <a:spAutoFit/>
+          </a:bodyPr>
+          <a:lstStyle/>
+          <a:p>
+            <a:pPr algn="l"/>
+            <a:r>
+              <a:rPr sz="1500" b="1">
+                <a:solidFill>
+                  <a:srgbClr val="F0B429"/>
+                </a:solidFill>
+                <a:latin typeface="Calibri"/>
+              </a:rPr>
+              <a:t>Progresso mensal</a:t>
+            </a:r>
+          </a:p>
+        </p:txBody>
+      </p:sp>
+      <p:sp>
+        <p:nvSpPr>
+          <p:cNvPr id="9" name="TextBox 8"/>
+          <p:cNvSpPr txBox="1"/>
+          <p:nvPr/>
+        </p:nvSpPr>
+        <p:spPr>
+          <a:xfrm>
+            <a:off x="3566160" y="2606039"/>
+            <a:ext cx="2331720" cy="2971799"/>
+          </a:xfrm>
+          <a:prstGeom prst="rect">
+            <a:avLst/>
+          </a:prstGeom>
+          <a:noFill/>
+        </p:spPr>
+        <p:txBody>
+          <a:bodyPr wrap="square">
+            <a:spAutoFit/>
+          </a:bodyPr>
+          <a:lstStyle/>
+          <a:p>
+            <a:pPr algn="l"/>
+            <a:r>
+              <a:rPr sz="1150" b="0">
+                <a:solidFill>
+                  <a:srgbClr val="CADCFC"/>
+                </a:solidFill>
+                <a:latin typeface="Calibri"/>
+              </a:rPr>
+              <a:t>O histórico do que foi feito, quando e por quê — fatiado por mês para não pesar no contexto. Cada tarefa concluída vira uma entrada curta.</a:t>
+            </a:r>
+          </a:p>
+        </p:txBody>
+      </p:sp>
+      <p:sp>
+        <p:nvSpPr>
+          <p:cNvPr id="10" name="Rectangle 9"/>
+          <p:cNvSpPr/>
+          <p:nvPr/>
+        </p:nvSpPr>
+        <p:spPr>
+          <a:xfrm>
+            <a:off x="6217920" y="1737360"/>
+            <a:ext cx="2606040" cy="3977639"/>
+          </a:xfrm>
+          <a:prstGeom prst="rect">
+            <a:avLst/>
+          </a:prstGeom>
+          <a:solidFill>
+            <a:srgbClr val="27336F"/>
+          </a:solidFill>
+          <a:ln>
+            <a:noFill/>
+          </a:ln>
+          <a:effectLst/>
+        </p:spPr>
+        <p:style>
+          <a:lnRef idx="1">
+            <a:schemeClr val="accent1"/>
+          </a:lnRef>
+          <a:fillRef idx="3">
+            <a:schemeClr val="accent1"/>
+          </a:fillRef>
+          <a:effectRef idx="2">
+            <a:schemeClr val="accent1"/>
+          </a:effectRef>
+          <a:fontRef idx="minor">
+            <a:schemeClr val="lt1"/>
+          </a:fontRef>
+        </p:style>
+        <p:txBody>
+          <a:bodyPr rtlCol="0" anchor="ctr"/>
+          <a:lstStyle/>
+          <a:p>
+            <a:pPr algn="ctr"/>
+          </a:p>
+        </p:txBody>
+      </p:sp>
+      <p:sp>
+        <p:nvSpPr>
+          <p:cNvPr id="11" name="TextBox 10"/>
+          <p:cNvSpPr txBox="1"/>
+          <p:nvPr/>
+        </p:nvSpPr>
+        <p:spPr>
+          <a:xfrm>
+            <a:off x="6355080" y="1965960"/>
+            <a:ext cx="2331720" cy="548640"/>
+          </a:xfrm>
+          <a:prstGeom prst="rect">
+            <a:avLst/>
+          </a:prstGeom>
+          <a:noFill/>
+        </p:spPr>
+        <p:txBody>
+          <a:bodyPr wrap="square">
+            <a:spAutoFit/>
+          </a:bodyPr>
+          <a:lstStyle/>
+          <a:p>
+            <a:pPr algn="l"/>
+            <a:r>
+              <a:rPr sz="1500" b="1">
+                <a:solidFill>
+                  <a:srgbClr val="F0B429"/>
+                </a:solidFill>
+                <a:latin typeface="Calibri"/>
+              </a:rPr>
+              <a:t>Plano antes de agir</a:t>
+            </a:r>
+          </a:p>
+        </p:txBody>
+      </p:sp>
+      <p:sp>
+        <p:nvSpPr>
+          <p:cNvPr id="12" name="TextBox 11"/>
+          <p:cNvSpPr txBox="1"/>
+          <p:nvPr/>
+        </p:nvSpPr>
+        <p:spPr>
+          <a:xfrm>
+            <a:off x="6355080" y="2606039"/>
+            <a:ext cx="2331720" cy="2971799"/>
+          </a:xfrm>
+          <a:prstGeom prst="rect">
+            <a:avLst/>
+          </a:prstGeom>
+          <a:noFill/>
+        </p:spPr>
+        <p:txBody>
+          <a:bodyPr wrap="square">
+            <a:spAutoFit/>
+          </a:bodyPr>
+          <a:lstStyle/>
+          <a:p>
+            <a:pPr algn="l"/>
+            <a:r>
+              <a:rPr sz="1150" b="0">
+                <a:solidFill>
+                  <a:srgbClr val="CADCFC"/>
+                </a:solidFill>
+                <a:latin typeface="Calibri"/>
+              </a:rPr>
+              <a:t>Antes de tocar no código, a IA devolve um relatório: sistema, arquivos lidos, área impactada, risco e ação planejada. Você aprova antes.</a:t>
+            </a:r>
+          </a:p>
+        </p:txBody>
+      </p:sp>
+      <p:sp>
+        <p:nvSpPr>
+          <p:cNvPr id="13" name="Rectangle 12"/>
+          <p:cNvSpPr/>
+          <p:nvPr/>
+        </p:nvSpPr>
+        <p:spPr>
+          <a:xfrm>
+            <a:off x="9006840" y="1737360"/>
+            <a:ext cx="2606040" cy="3977639"/>
+          </a:xfrm>
+          <a:prstGeom prst="rect">
+            <a:avLst/>
+          </a:prstGeom>
+          <a:solidFill>
+            <a:srgbClr val="27336F"/>
+          </a:solidFill>
+          <a:ln>
+            <a:noFill/>
+          </a:ln>
+          <a:effectLst/>
+        </p:spPr>
+        <p:style>
+          <a:lnRef idx="1">
+            <a:schemeClr val="accent1"/>
+          </a:lnRef>
+          <a:fillRef idx="3">
+            <a:schemeClr val="accent1"/>
+          </a:fillRef>
+          <a:effectRef idx="2">
+            <a:schemeClr val="accent1"/>
+          </a:effectRef>
+          <a:fontRef idx="minor">
+            <a:schemeClr val="lt1"/>
+          </a:fontRef>
+        </p:style>
+        <p:txBody>
+          <a:bodyPr rtlCol="0" anchor="ctr"/>
+          <a:lstStyle/>
+          <a:p>
+            <a:pPr algn="ctr"/>
+          </a:p>
+        </p:txBody>
+      </p:sp>
+      <p:sp>
+        <p:nvSpPr>
+          <p:cNvPr id="14" name="TextBox 13"/>
+          <p:cNvSpPr txBox="1"/>
+          <p:nvPr/>
+        </p:nvSpPr>
+        <p:spPr>
+          <a:xfrm>
+            <a:off x="9144000" y="1965960"/>
+            <a:ext cx="2331720" cy="548640"/>
+          </a:xfrm>
+          <a:prstGeom prst="rect">
+            <a:avLst/>
+          </a:prstGeom>
+          <a:noFill/>
+        </p:spPr>
+        <p:txBody>
+          <a:bodyPr wrap="square">
+            <a:spAutoFit/>
+          </a:bodyPr>
+          <a:lstStyle/>
+          <a:p>
+            <a:pPr algn="l"/>
+            <a:r>
+              <a:rPr sz="1500" b="1">
+                <a:solidFill>
+                  <a:srgbClr val="F0B429"/>
+                </a:solidFill>
+                <a:latin typeface="Calibri"/>
+              </a:rPr>
+              <a:t>Verificação provada</a:t>
+            </a:r>
+          </a:p>
+        </p:txBody>
+      </p:sp>
+      <p:sp>
+        <p:nvSpPr>
+          <p:cNvPr id="15" name="TextBox 14"/>
+          <p:cNvSpPr txBox="1"/>
+          <p:nvPr/>
+        </p:nvSpPr>
+        <p:spPr>
+          <a:xfrm>
+            <a:off x="9144000" y="2606039"/>
+            <a:ext cx="2331720" cy="2971799"/>
+          </a:xfrm>
+          <a:prstGeom prst="rect">
+            <a:avLst/>
+          </a:prstGeom>
+          <a:noFill/>
+        </p:spPr>
+        <p:txBody>
+          <a:bodyPr wrap="square">
+            <a:spAutoFit/>
+          </a:bodyPr>
+          <a:lstStyle/>
+          <a:p>
+            <a:pPr algn="l"/>
+            <a:r>
+              <a:rPr sz="1150" b="0">
+                <a:solidFill>
+                  <a:srgbClr val="CADCFC"/>
+                </a:solidFill>
+                <a:latin typeface="Calibri"/>
+              </a:rPr>
+              <a:t>Ao concluir, a IA relata o resultado observado (não deduzido) e, ao corrigir bugs, os gêmeos varridos (TWINS). Confiança com evidência.</a:t>
+            </a:r>
+          </a:p>
+        </p:txBody>
+      </p:sp>
+    </p:spTree>
+  </p:cSld>
+  <p:clrMapOvr>
+    <a:masterClrMapping/>
+  </p:clrMapOvr>
+</p:sld>
+</file>
+
+<file path=ppt/slides/slide7.xml><?xml version="1.0" encoding="utf-8"?>
 <p:sld xmlns:a="http://schemas.openxmlformats.org/drawingml/2006/main" xmlns:r="http://schemas.openxmlformats.org/officeDocument/2006/relationships" xmlns:p="http://schemas.openxmlformats.org/presentationml/2006/main">
   <p:cSld name="Slide 6">
     <p:bg>
@@ -6980,7 +8120,7 @@
 </p:sld>
 </file>
 
-<file path=ppt/slides/slide7.xml><?xml version="1.0" encoding="utf-8"?>
+<file path=ppt/slides/slide8.xml><?xml version="1.0" encoding="utf-8"?>
 <p:sld xmlns:a="http://schemas.openxmlformats.org/drawingml/2006/main" xmlns:r="http://schemas.openxmlformats.org/officeDocument/2006/relationships" xmlns:p="http://schemas.openxmlformats.org/presentationml/2006/main">
   <p:cSld name="Slide 7">
     <p:bg>
@@ -7598,7 +8738,7 @@
 </p:sld>
 </file>
 
-<file path=ppt/slides/slide8.xml><?xml version="1.0" encoding="utf-8"?>
+<file path=ppt/slides/slide9.xml><?xml version="1.0" encoding="utf-8"?>
 <p:sld xmlns:a="http://schemas.openxmlformats.org/drawingml/2006/main" xmlns:r="http://schemas.openxmlformats.org/officeDocument/2006/relationships" xmlns:p="http://schemas.openxmlformats.org/presentationml/2006/main">
   <p:cSld name="Slide 8">
     <p:bg>
@@ -8612,593 +9752,6 @@
               <a:t>Open-source sob Licença MIT, com créditos a ideias externas adotadas e processo de melhoria contínua</a:t>
             </a:r>
             <a:endParaRPr lang="en-US" sz="1150" dirty="0"/>
-          </a:p>
-        </p:txBody>
-      </p:sp>
-    </p:spTree>
-  </p:cSld>
-  <p:clrMapOvr>
-    <a:masterClrMapping/>
-  </p:clrMapOvr>
-</p:sld>
-</file>
-
-<file path=ppt/slides/slide9.xml><?xml version="1.0" encoding="utf-8"?>
-<p:sld xmlns:a="http://schemas.openxmlformats.org/drawingml/2006/main" xmlns:r="http://schemas.openxmlformats.org/officeDocument/2006/relationships" xmlns:p="http://schemas.openxmlformats.org/presentationml/2006/main">
-  <p:cSld name="Slide 9">
-    <p:bg>
-      <p:bgPr>
-        <a:solidFill>
-          <a:srgbClr val="FFFFFF"/>
-        </a:solidFill>
-      </p:bgPr>
-    </p:bg>
-    <p:spTree>
-      <p:nvGrpSpPr>
-        <p:cNvPr id="1" name=""/>
-        <p:cNvGrpSpPr/>
-        <p:nvPr/>
-      </p:nvGrpSpPr>
-      <p:grpSpPr>
-        <a:xfrm>
-          <a:off x="0" y="0"/>
-          <a:ext cx="0" cy="0"/>
-          <a:chOff x="0" y="0"/>
-          <a:chExt cx="0" cy="0"/>
-        </a:xfrm>
-      </p:grpSpPr>
-      <p:sp>
-        <p:nvSpPr>
-          <p:cNvPr id="2" name="Text 0"/>
-          <p:cNvSpPr/>
-          <p:nvPr/>
-        </p:nvSpPr>
-        <p:spPr>
-          <a:xfrm>
-            <a:off x="640080" y="502920"/>
-            <a:ext cx="10972800" cy="731520"/>
-          </a:xfrm>
-          <a:prstGeom prst="rect">
-            <a:avLst/>
-          </a:prstGeom>
-          <a:noFill/>
-          <a:ln/>
-        </p:spPr>
-        <p:txBody>
-          <a:bodyPr wrap="square" lIns="0" tIns="0" rIns="0" bIns="0" rtlCol="0" anchor="ctr"/>
-          <a:lstStyle/>
-          <a:p>
-            <a:pPr indent="0" marL="0">
-              <a:buNone/>
-            </a:pPr>
-            <a:r>
-              <a:rPr lang="en-US" sz="3800" b="1" dirty="0">
-                <a:solidFill>
-                  <a:srgbClr val="1E2761"/>
-                </a:solidFill>
-                <a:latin typeface="Cambria" pitchFamily="34" charset="0"/>
-                <a:ea typeface="Cambria" pitchFamily="34" charset="-122"/>
-                <a:cs typeface="Cambria" pitchFamily="34" charset="-120"/>
-              </a:rPr>
-              <a:t>Implantação em 3 passos</a:t>
-            </a:r>
-            <a:endParaRPr lang="en-US" sz="3800" dirty="0"/>
-          </a:p>
-        </p:txBody>
-      </p:sp>
-      <p:sp>
-        <p:nvSpPr>
-          <p:cNvPr id="3" name="Shape 1"/>
-          <p:cNvSpPr/>
-          <p:nvPr/>
-        </p:nvSpPr>
-        <p:spPr>
-          <a:xfrm>
-            <a:off x="822960" y="1828800"/>
-            <a:ext cx="914400" cy="914400"/>
-          </a:xfrm>
-          <a:prstGeom prst="ellipse">
-            <a:avLst/>
-          </a:prstGeom>
-          <a:solidFill>
-            <a:srgbClr val="1E2761"/>
-          </a:solidFill>
-          <a:ln/>
-        </p:spPr>
-        <p:txBody>
-          <a:bodyPr/>
-          <a:p/>
-        </p:txBody>
-      </p:sp>
-      <p:sp>
-        <p:nvSpPr>
-          <p:cNvPr id="4" name="Text 2"/>
-          <p:cNvSpPr/>
-          <p:nvPr/>
-        </p:nvSpPr>
-        <p:spPr>
-          <a:xfrm>
-            <a:off x="822960" y="1828800"/>
-            <a:ext cx="914400" cy="914400"/>
-          </a:xfrm>
-          <a:prstGeom prst="rect">
-            <a:avLst/>
-          </a:prstGeom>
-          <a:noFill/>
-          <a:ln/>
-        </p:spPr>
-        <p:txBody>
-          <a:bodyPr wrap="square" lIns="0" tIns="0" rIns="0" bIns="0" rtlCol="0" anchor="ctr"/>
-          <a:lstStyle/>
-          <a:p>
-            <a:pPr algn="ctr" indent="0" marL="0">
-              <a:buNone/>
-            </a:pPr>
-            <a:r>
-              <a:rPr lang="en-US" sz="3000" b="1" dirty="0">
-                <a:solidFill>
-                  <a:srgbClr val="F0B429"/>
-                </a:solidFill>
-                <a:latin typeface="Cambria" pitchFamily="34" charset="0"/>
-                <a:ea typeface="Cambria" pitchFamily="34" charset="-122"/>
-                <a:cs typeface="Cambria" pitchFamily="34" charset="-120"/>
-              </a:rPr>
-              <a:t>1</a:t>
-            </a:r>
-            <a:endParaRPr lang="en-US" sz="3000" dirty="0"/>
-          </a:p>
-        </p:txBody>
-      </p:sp>
-      <p:sp>
-        <p:nvSpPr>
-          <p:cNvPr id="5" name="Text 3"/>
-          <p:cNvSpPr/>
-          <p:nvPr/>
-        </p:nvSpPr>
-        <p:spPr>
-          <a:xfrm>
-            <a:off x="2057400" y="1737360"/>
-            <a:ext cx="2011680" cy="548640"/>
-          </a:xfrm>
-          <a:prstGeom prst="rect">
-            <a:avLst/>
-          </a:prstGeom>
-          <a:noFill/>
-          <a:ln/>
-        </p:spPr>
-        <p:txBody>
-          <a:bodyPr wrap="square" lIns="0" tIns="0" rIns="0" bIns="0" rtlCol="0" anchor="ctr"/>
-          <a:lstStyle/>
-          <a:p>
-            <a:pPr indent="0" marL="0">
-              <a:buNone/>
-            </a:pPr>
-            <a:r>
-              <a:rPr lang="en-US" sz="2000" b="1" dirty="0">
-                <a:solidFill>
-                  <a:srgbClr val="1E2761"/>
-                </a:solidFill>
-                <a:latin typeface="Calibri" pitchFamily="34" charset="0"/>
-                <a:ea typeface="Calibri" pitchFamily="34" charset="-122"/>
-                <a:cs typeface="Calibri" pitchFamily="34" charset="-120"/>
-              </a:rPr>
-              <a:t>Copie</a:t>
-            </a:r>
-            <a:endParaRPr lang="en-US" sz="2000" dirty="0"/>
-          </a:p>
-        </p:txBody>
-      </p:sp>
-      <p:sp>
-        <p:nvSpPr>
-          <p:cNvPr id="6" name="Text 4"/>
-          <p:cNvSpPr/>
-          <p:nvPr/>
-        </p:nvSpPr>
-        <p:spPr>
-          <a:xfrm>
-            <a:off x="2057400" y="2240280"/>
-            <a:ext cx="8961120" cy="731520"/>
-          </a:xfrm>
-          <a:prstGeom prst="rect">
-            <a:avLst/>
-          </a:prstGeom>
-          <a:noFill/>
-          <a:ln/>
-        </p:spPr>
-        <p:txBody>
-          <a:bodyPr wrap="square" lIns="0" tIns="0" rIns="0" bIns="0" rtlCol="0" anchor="ctr"/>
-          <a:lstStyle/>
-          <a:p>
-            <a:pPr indent="0" marL="0">
-              <a:buNone/>
-            </a:pPr>
-            <a:r>
-              <a:rPr lang="en-US" sz="1450" dirty="0">
-                <a:solidFill>
-                  <a:srgbClr val="5A6B8C"/>
-                </a:solidFill>
-                <a:latin typeface="Calibri" pitchFamily="34" charset="0"/>
-                <a:ea typeface="Calibri" pitchFamily="34" charset="-122"/>
-                <a:cs typeface="Calibri" pitchFamily="34" charset="-120"/>
-              </a:rPr>
-              <a:t>Copie a pasta template para onde sua documentação vai morar e renomeie.</a:t>
-            </a:r>
-            <a:endParaRPr lang="en-US" sz="1450" dirty="0"/>
-          </a:p>
-        </p:txBody>
-      </p:sp>
-      <p:sp>
-        <p:nvSpPr>
-          <p:cNvPr id="7" name="Shape 5"/>
-          <p:cNvSpPr/>
-          <p:nvPr/>
-        </p:nvSpPr>
-        <p:spPr>
-          <a:xfrm>
-            <a:off x="822960" y="3246120"/>
-            <a:ext cx="914400" cy="914400"/>
-          </a:xfrm>
-          <a:prstGeom prst="ellipse">
-            <a:avLst/>
-          </a:prstGeom>
-          <a:solidFill>
-            <a:srgbClr val="1E2761"/>
-          </a:solidFill>
-          <a:ln/>
-        </p:spPr>
-        <p:txBody>
-          <a:bodyPr/>
-          <a:p/>
-        </p:txBody>
-      </p:sp>
-      <p:sp>
-        <p:nvSpPr>
-          <p:cNvPr id="8" name="Text 6"/>
-          <p:cNvSpPr/>
-          <p:nvPr/>
-        </p:nvSpPr>
-        <p:spPr>
-          <a:xfrm>
-            <a:off x="822960" y="3246120"/>
-            <a:ext cx="914400" cy="914400"/>
-          </a:xfrm>
-          <a:prstGeom prst="rect">
-            <a:avLst/>
-          </a:prstGeom>
-          <a:noFill/>
-          <a:ln/>
-        </p:spPr>
-        <p:txBody>
-          <a:bodyPr wrap="square" lIns="0" tIns="0" rIns="0" bIns="0" rtlCol="0" anchor="ctr"/>
-          <a:lstStyle/>
-          <a:p>
-            <a:pPr algn="ctr" indent="0" marL="0">
-              <a:buNone/>
-            </a:pPr>
-            <a:r>
-              <a:rPr lang="en-US" sz="3000" b="1" dirty="0">
-                <a:solidFill>
-                  <a:srgbClr val="F0B429"/>
-                </a:solidFill>
-                <a:latin typeface="Cambria" pitchFamily="34" charset="0"/>
-                <a:ea typeface="Cambria" pitchFamily="34" charset="-122"/>
-                <a:cs typeface="Cambria" pitchFamily="34" charset="-120"/>
-              </a:rPr>
-              <a:t>2</a:t>
-            </a:r>
-            <a:endParaRPr lang="en-US" sz="3000" dirty="0"/>
-          </a:p>
-        </p:txBody>
-      </p:sp>
-      <p:sp>
-        <p:nvSpPr>
-          <p:cNvPr id="9" name="Text 7"/>
-          <p:cNvSpPr/>
-          <p:nvPr/>
-        </p:nvSpPr>
-        <p:spPr>
-          <a:xfrm>
-            <a:off x="2057400" y="3154680"/>
-            <a:ext cx="2011680" cy="548640"/>
-          </a:xfrm>
-          <a:prstGeom prst="rect">
-            <a:avLst/>
-          </a:prstGeom>
-          <a:noFill/>
-          <a:ln/>
-        </p:spPr>
-        <p:txBody>
-          <a:bodyPr wrap="square" lIns="0" tIns="0" rIns="0" bIns="0" rtlCol="0" anchor="ctr"/>
-          <a:lstStyle/>
-          <a:p>
-            <a:pPr indent="0" marL="0">
-              <a:buNone/>
-            </a:pPr>
-            <a:r>
-              <a:rPr lang="en-US" sz="2000" b="1" dirty="0">
-                <a:solidFill>
-                  <a:srgbClr val="1E2761"/>
-                </a:solidFill>
-                <a:latin typeface="Calibri" pitchFamily="34" charset="0"/>
-                <a:ea typeface="Calibri" pitchFamily="34" charset="-122"/>
-                <a:cs typeface="Calibri" pitchFamily="34" charset="-120"/>
-              </a:rPr>
-              <a:t>Responda</a:t>
-            </a:r>
-            <a:endParaRPr lang="en-US" sz="2000" dirty="0"/>
-          </a:p>
-        </p:txBody>
-      </p:sp>
-      <p:sp>
-        <p:nvSpPr>
-          <p:cNvPr id="10" name="Text 8"/>
-          <p:cNvSpPr/>
-          <p:nvPr/>
-        </p:nvSpPr>
-        <p:spPr>
-          <a:xfrm>
-            <a:off x="2057400" y="3657600"/>
-            <a:ext cx="8961120" cy="731520"/>
-          </a:xfrm>
-          <a:prstGeom prst="rect">
-            <a:avLst/>
-          </a:prstGeom>
-          <a:noFill/>
-          <a:ln/>
-        </p:spPr>
-        <p:txBody>
-          <a:bodyPr wrap="square" lIns="0" tIns="0" rIns="0" bIns="0" rtlCol="0" anchor="ctr"/>
-          <a:lstStyle/>
-          <a:p>
-            <a:pPr indent="0" marL="0">
-              <a:buNone/>
-            </a:pPr>
-            <a:r>
-              <a:rPr lang="en-US" sz="1450" dirty="0">
-                <a:solidFill>
-                  <a:srgbClr val="5A6B8C"/>
-                </a:solidFill>
-                <a:latin typeface="Calibri" pitchFamily="34" charset="0"/>
-                <a:ea typeface="Calibri" pitchFamily="34" charset="-122"/>
-                <a:cs typeface="Calibri" pitchFamily="34" charset="-120"/>
-              </a:rPr>
-              <a:t>Cole o prompt de setup na sua IA e responda ao questionário — ela preenche tudo e roda o validador até 0 erros.</a:t>
-            </a:r>
-            <a:endParaRPr lang="en-US" sz="1450" dirty="0"/>
-          </a:p>
-        </p:txBody>
-      </p:sp>
-      <p:sp>
-        <p:nvSpPr>
-          <p:cNvPr id="11" name="Shape 9"/>
-          <p:cNvSpPr/>
-          <p:nvPr/>
-        </p:nvSpPr>
-        <p:spPr>
-          <a:xfrm>
-            <a:off x="822960" y="4663440"/>
-            <a:ext cx="914400" cy="914400"/>
-          </a:xfrm>
-          <a:prstGeom prst="ellipse">
-            <a:avLst/>
-          </a:prstGeom>
-          <a:solidFill>
-            <a:srgbClr val="1E2761"/>
-          </a:solidFill>
-          <a:ln/>
-        </p:spPr>
-        <p:txBody>
-          <a:bodyPr/>
-          <a:p/>
-        </p:txBody>
-      </p:sp>
-      <p:sp>
-        <p:nvSpPr>
-          <p:cNvPr id="12" name="Text 10"/>
-          <p:cNvSpPr/>
-          <p:nvPr/>
-        </p:nvSpPr>
-        <p:spPr>
-          <a:xfrm>
-            <a:off x="822960" y="4663440"/>
-            <a:ext cx="914400" cy="914400"/>
-          </a:xfrm>
-          <a:prstGeom prst="rect">
-            <a:avLst/>
-          </a:prstGeom>
-          <a:noFill/>
-          <a:ln/>
-        </p:spPr>
-        <p:txBody>
-          <a:bodyPr wrap="square" lIns="0" tIns="0" rIns="0" bIns="0" rtlCol="0" anchor="ctr"/>
-          <a:lstStyle/>
-          <a:p>
-            <a:pPr algn="ctr" indent="0" marL="0">
-              <a:buNone/>
-            </a:pPr>
-            <a:r>
-              <a:rPr lang="en-US" sz="3000" b="1" dirty="0">
-                <a:solidFill>
-                  <a:srgbClr val="F0B429"/>
-                </a:solidFill>
-                <a:latin typeface="Cambria" pitchFamily="34" charset="0"/>
-                <a:ea typeface="Cambria" pitchFamily="34" charset="-122"/>
-                <a:cs typeface="Cambria" pitchFamily="34" charset="-120"/>
-              </a:rPr>
-              <a:t>3</a:t>
-            </a:r>
-            <a:endParaRPr lang="en-US" sz="3000" dirty="0"/>
-          </a:p>
-        </p:txBody>
-      </p:sp>
-      <p:sp>
-        <p:nvSpPr>
-          <p:cNvPr id="13" name="Text 11"/>
-          <p:cNvSpPr/>
-          <p:nvPr/>
-        </p:nvSpPr>
-        <p:spPr>
-          <a:xfrm>
-            <a:off x="2057400" y="4572000"/>
-            <a:ext cx="2011680" cy="548640"/>
-          </a:xfrm>
-          <a:prstGeom prst="rect">
-            <a:avLst/>
-          </a:prstGeom>
-          <a:noFill/>
-          <a:ln/>
-        </p:spPr>
-        <p:txBody>
-          <a:bodyPr wrap="square" lIns="0" tIns="0" rIns="0" bIns="0" rtlCol="0" anchor="ctr"/>
-          <a:lstStyle/>
-          <a:p>
-            <a:pPr indent="0" marL="0">
-              <a:buNone/>
-            </a:pPr>
-            <a:r>
-              <a:rPr lang="en-US" sz="2000" b="1" dirty="0">
-                <a:solidFill>
-                  <a:srgbClr val="1E2761"/>
-                </a:solidFill>
-                <a:latin typeface="Calibri" pitchFamily="34" charset="0"/>
-                <a:ea typeface="Calibri" pitchFamily="34" charset="-122"/>
-                <a:cs typeface="Calibri" pitchFamily="34" charset="-120"/>
-              </a:rPr>
-              <a:t>Aponte</a:t>
-            </a:r>
-            <a:endParaRPr lang="en-US" sz="2000" dirty="0"/>
-          </a:p>
-        </p:txBody>
-      </p:sp>
-      <p:sp>
-        <p:nvSpPr>
-          <p:cNvPr id="14" name="Text 12"/>
-          <p:cNvSpPr/>
-          <p:nvPr/>
-        </p:nvSpPr>
-        <p:spPr>
-          <a:xfrm>
-            <a:off x="2057400" y="5074920"/>
-            <a:ext cx="8961120" cy="731520"/>
-          </a:xfrm>
-          <a:prstGeom prst="rect">
-            <a:avLst/>
-          </a:prstGeom>
-          <a:noFill/>
-          <a:ln/>
-        </p:spPr>
-        <p:txBody>
-          <a:bodyPr wrap="square" lIns="0" tIns="0" rIns="0" bIns="0" rtlCol="0" anchor="ctr"/>
-          <a:lstStyle/>
-          <a:p>
-            <a:pPr indent="0" marL="0">
-              <a:buNone/>
-            </a:pPr>
-            <a:r>
-              <a:rPr lang="en-US" sz="1450" dirty="0">
-                <a:solidFill>
-                  <a:srgbClr val="5A6B8C"/>
-                </a:solidFill>
-                <a:latin typeface="Calibri" pitchFamily="34" charset="0"/>
-                <a:ea typeface="Calibri" pitchFamily="34" charset="-122"/>
-                <a:cs typeface="Calibri" pitchFamily="34" charset="-120"/>
-              </a:rPr>
-              <a:t>Referencie o hub no arquivo de instruções de cada projeto. Pronto: toda sessão de IA começa com o norte certo.</a:t>
-            </a:r>
-            <a:endParaRPr lang="en-US" sz="1450" dirty="0"/>
-          </a:p>
-        </p:txBody>
-      </p:sp>
-      <p:sp>
-        <p:nvSpPr>
-          <p:cNvPr id="15" name="Shape 13"/>
-          <p:cNvSpPr/>
-          <p:nvPr/>
-        </p:nvSpPr>
-        <p:spPr>
-          <a:xfrm>
-            <a:off x="640080" y="5897880"/>
-            <a:ext cx="10881360" cy="685800"/>
-          </a:xfrm>
-          <a:prstGeom prst="roundRect">
-            <a:avLst>
-              <a:gd name="adj" fmla="val 13333"/>
-            </a:avLst>
-          </a:prstGeom>
-          <a:solidFill>
-            <a:srgbClr val="EFF4FC"/>
-          </a:solidFill>
-          <a:ln/>
-        </p:spPr>
-        <p:txBody>
-          <a:bodyPr/>
-          <a:p/>
-        </p:txBody>
-      </p:sp>
-      <p:sp>
-        <p:nvSpPr>
-          <p:cNvPr id="16" name="Text 14"/>
-          <p:cNvSpPr/>
-          <p:nvPr/>
-        </p:nvSpPr>
-        <p:spPr>
-          <a:xfrm>
-            <a:off x="914400" y="5897880"/>
-            <a:ext cx="10332720" cy="685800"/>
-          </a:xfrm>
-          <a:prstGeom prst="rect">
-            <a:avLst/>
-          </a:prstGeom>
-          <a:noFill/>
-          <a:ln/>
-        </p:spPr>
-        <p:txBody>
-          <a:bodyPr wrap="square" lIns="0" tIns="0" rIns="0" bIns="0" rtlCol="0" anchor="ctr"/>
-          <a:lstStyle/>
-          <a:p>
-            <a:pPr algn="ctr" indent="0" marL="0">
-              <a:buNone/>
-            </a:pPr>
-            <a:r>
-              <a:rPr lang="en-US" sz="1400" dirty="0">
-                <a:solidFill>
-                  <a:srgbClr val="5A6B8C"/>
-                </a:solidFill>
-                <a:latin typeface="Calibri" pitchFamily="34" charset="0"/>
-                <a:ea typeface="Calibri" pitchFamily="34" charset="-122"/>
-                <a:cs typeface="Calibri" pitchFamily="34" charset="-120"/>
-              </a:rPr>
-              <a:t>Tempo típico até a primeira versão útil: </a:t>
-            </a:r>
-            <a:pPr algn="ctr" indent="0" marL="0">
-              <a:buNone/>
-            </a:pPr>
-            <a:r>
-              <a:rPr lang="en-US" sz="1400" b="1" dirty="0">
-                <a:solidFill>
-                  <a:srgbClr val="1E2761"/>
-                </a:solidFill>
-                <a:latin typeface="Calibri" pitchFamily="34" charset="0"/>
-                <a:ea typeface="Calibri" pitchFamily="34" charset="-122"/>
-                <a:cs typeface="Calibri" pitchFamily="34" charset="-120"/>
-              </a:rPr>
-              <a:t>1 a 2 horas</a:t>
-            </a:r>
-            <a:pPr algn="ctr" indent="0" marL="0">
-              <a:buNone/>
-            </a:pPr>
-            <a:r>
-              <a:rPr lang="en-US" sz="1400" dirty="0">
-                <a:solidFill>
-                  <a:srgbClr val="5A6B8C"/>
-                </a:solidFill>
-                <a:latin typeface="Calibri" pitchFamily="34" charset="0"/>
-                <a:ea typeface="Calibri" pitchFamily="34" charset="-122"/>
-                <a:cs typeface="Calibri" pitchFamily="34" charset="-120"/>
-              </a:rPr>
-              <a:t>  ·  funciona com Claude Code, Cursor, Copilot e afins</a:t>
-            </a:r>
-            <a:endParaRPr lang="en-US" sz="1400" dirty="0"/>
           </a:p>
         </p:txBody>
       </p:sp>

</xml_diff>